<commit_message>
Titoli aggiornati: chiusura della lezione 02, schede 03, 04 e 06, icona della 04 nell'indice
- Lezione 02: la prossima lezione è «Ormeggi, ancoraggi, carte e segnali»
- Addendum schede: scheda 03 con ormeggi, ancore, carte e segnalamento;
  scheda 04 sul carteggio (M = V × Tm : 60, carburante, prora e rotta,
  declinazione e deviazione) e la condotta sottocosta; scheda 06 senza fari
  e IALA (passati nella 03), con nebbia, sorpasso, dotazioni e soccorso
- Indice: icona del compasso per la lezione 04 nella tabella delle lezioni
- Export di lezione 02, addendum e indice

Co-Authored-By: Claude Opus 5.5 <noreply@anthropic.com>
Claude-Session: https://claude.ai/code/session_01JPL34mYzgWNhRELUonzupj
</commit_message>
<xml_diff>
--- a/corso/export/pptx/Addendum - Schede riassuntive.pptx
+++ b/corso/export/pptx/Addendum - Schede riassuntive.pptx
@@ -2564,7 +2564,7 @@
           <a:lstStyle/>
           <a:p>
             <a:r>
-              <a:t>Scheda della lezione 3. Esempi: 15 nodi per 45 minuti = 11,25 miglia (1.7.5-31); 18 miglia a 7 nodi = 2 h 34′ (1.7.5-65).</a:t>
+              <a:t>Scheda della lezione 3: ormeggi e ancoraggi, cartografia, fari e segnalamento AISM-IALA. Cardinali: N luce continua (scintillante), E 3 lampi, S 6 lampi più un lampo lungo, W 9 lampi.</a:t>
             </a:r>
           </a:p>
         </p:txBody>
@@ -2634,7 +2634,7 @@
           <a:lstStyle/>
           <a:p>
             <a:r>
-              <a:t>Scheda della lezione 3. Esempi: 15 nodi per 45 minuti = 11,25 miglia (1.7.5-31); 18 miglia a 7 nodi = 2 h 34′ (1.7.5-65).</a:t>
+              <a:t>Scheda della lezione 3: ormeggi e ancoraggi, cartografia, fari e segnalamento AISM-IALA. Cardinali: N luce continua (scintillante), E 3 lampi, S 6 lampi più un lampo lungo, W 9 lampi.</a:t>
             </a:r>
           </a:p>
         </p:txBody>
@@ -2704,7 +2704,7 @@
           <a:lstStyle/>
           <a:p>
             <a:r>
-              <a:t>Scheda della lezione 4. Quiz 1.4.3 (ancoraggio), 1.4.2 (distanze), 1.7.3 (bussola).</a:t>
+              <a:t>Scheda della lezione 4. Esempi: 15 nodi per 45 minuti = 15 × 45 : 60 = 11,25 miglia (1.7.5-31); 18 miglia a 7 nodi = 18 : 7 × 60 ≈ 154′ = 2 h 34′ (1.7.5-65). Quiz 1.7.4 (bussola), 1.7.5 (stima), 1.7.7 (prora e rotta), 1.2.3 (carburante), 1.4.2 (costa).</a:t>
             </a:r>
           </a:p>
         </p:txBody>
@@ -2774,7 +2774,7 @@
           <a:lstStyle/>
           <a:p>
             <a:r>
-              <a:t>Scheda della lezione 4. Quiz 1.4.3 (ancoraggio), 1.4.2 (distanze), 1.7.3 (bussola).</a:t>
+              <a:t>Scheda della lezione 4. Esempi: 15 nodi per 45 minuti = 15 × 45 : 60 = 11,25 miglia (1.7.5-31); 18 miglia a 7 nodi = 18 : 7 × 60 ≈ 154′ = 2 h 34′ (1.7.5-65). Quiz 1.7.4 (bussola), 1.7.5 (stima), 1.7.7 (prora e rotta), 1.2.3 (carburante), 1.4.2 (costa).</a:t>
             </a:r>
           </a:p>
         </p:txBody>

</xml_diff>

<commit_message>
Carteggio della lezione 05 spostato nella lezione 04
- lezione 04: nuovi capitoli 5 (navigazione costiera e punto nave) e 6
  (rilevamenti e GPS) con le loro verifiche; sette capitoli in 75 minuti,
  raccolta quiz rifatta su tutti gli argomenti (81 slide)
- lezione 05: solo COLREG in tre capitoli (fanali, segnali diurni e
  precedenze, regole di rotta); raccolta quiz con 15 nuovi quiz di
  fanali e precedenze al posto di quelli di carteggio (46 slide)
- indice del corso (slide 04 e 05), schede riassuntive 04 e 05,
  README, indice.md ed export aggiornati

Co-Authored-By: Claude Opus 5.5 <noreply@anthropic.com>
Claude-Session: https://claude.ai/code/session_01JPL34mYzgWNhRELUonzupj
</commit_message>
<xml_diff>
--- a/corso/export/pptx/Addendum - Schede riassuntive.pptx
+++ b/corso/export/pptx/Addendum - Schede riassuntive.pptx
@@ -604,7 +604,7 @@
           <a:lstStyle/>
           <a:p>
             <a:r>
-              <a:t>Scheda della lezione 5. GPS obbligatorio oltre 12 miglia. Tricolore in testa d'albero ammesso sotto i 20 m.</a:t>
+              <a:t>Scheda della lezione 5: fanali, segnali diurni, rischio di collisione e precedenze. Quiz 1.5.1 (fanali e segnali diurni) e 1.5.2 (prevenire gli abbordi).</a:t>
             </a:r>
           </a:p>
         </p:txBody>
@@ -674,7 +674,7 @@
           <a:lstStyle/>
           <a:p>
             <a:r>
-              <a:t>Scheda della lezione 5. GPS obbligatorio oltre 12 miglia. Tricolore in testa d'albero ammesso sotto i 20 m.</a:t>
+              <a:t>Scheda della lezione 5: fanali, segnali diurni, rischio di collisione e precedenze. Quiz 1.5.1 (fanali e segnali diurni) e 1.5.2 (prevenire gli abbordi).</a:t>
             </a:r>
           </a:p>
         </p:txBody>
@@ -2704,7 +2704,7 @@
           <a:lstStyle/>
           <a:p>
             <a:r>
-              <a:t>Scheda della lezione 4. Esempi: 15 nodi per 45 minuti = 15 × 45 : 60 = 11,25 miglia (1.7.5-31); 18 miglia a 7 nodi = 18 : 7 × 60 ≈ 154′ = 2 h 34′ (1.7.5-65). Quiz 1.7.4 (bussola), 1.7.5 (stima), 1.7.7 (prora e rotta), 1.2.3 (carburante), 1.4.2 (costa).</a:t>
+              <a:t>Scheda della lezione 4. Esempi: 15 nodi per 45 minuti = 15 × 45 : 60 = 11,25 miglia (1.7.5-31); 18 miglia a 7 nodi = 18 : 7 × 60 ≈ 154′ = 2 h 34′ (1.7.5-65). Quiz 1.7.4 (bussola), 1.7.5 (stima), 1.7.6 (navigazione costiera), 1.7.3 (GPS, obbligatorio oltre 12 miglia), 1.7.7 (prora e rotta), 1.2.3 (carburante), 1.4.2 (costa).</a:t>
             </a:r>
           </a:p>
         </p:txBody>
@@ -2774,7 +2774,7 @@
           <a:lstStyle/>
           <a:p>
             <a:r>
-              <a:t>Scheda della lezione 4. Esempi: 15 nodi per 45 minuti = 15 × 45 : 60 = 11,25 miglia (1.7.5-31); 18 miglia a 7 nodi = 18 : 7 × 60 ≈ 154′ = 2 h 34′ (1.7.5-65). Quiz 1.7.4 (bussola), 1.7.5 (stima), 1.7.7 (prora e rotta), 1.2.3 (carburante), 1.4.2 (costa).</a:t>
+              <a:t>Scheda della lezione 4. Esempi: 15 nodi per 45 minuti = 15 × 45 : 60 = 11,25 miglia (1.7.5-31); 18 miglia a 7 nodi = 18 : 7 × 60 ≈ 154′ = 2 h 34′ (1.7.5-65). Quiz 1.7.4 (bussola), 1.7.5 (stima), 1.7.6 (navigazione costiera), 1.7.3 (GPS, obbligatorio oltre 12 miglia), 1.7.7 (prora e rotta), 1.2.3 (carburante), 1.4.2 (costa).</a:t>
             </a:r>
           </a:p>
         </p:txBody>

</xml_diff>